<commit_message>
added creating gif animations
</commit_message>
<xml_diff>
--- a/resources/Лазарев.pptx
+++ b/resources/Лазарев.pptx
@@ -121,7 +121,7 @@
             <a:srgbClr val="A4A3A4"/>
           </p15:clr>
         </p15:guide>
-        <p15:guide id="2" pos="3795" userDrawn="1">
+        <p15:guide id="2" pos="3613" userDrawn="1">
           <p15:clr>
             <a:srgbClr val="A4A3A4"/>
           </p15:clr>
@@ -3841,8 +3841,8 @@
         </p:nvSpPr>
         <p:spPr>
           <a:xfrm>
-            <a:off x="499872" y="628601"/>
-            <a:ext cx="6156960" cy="461665"/>
+            <a:off x="526196" y="215275"/>
+            <a:ext cx="8810844" cy="584775"/>
           </a:xfrm>
           <a:prstGeom prst="rect">
             <a:avLst/>
@@ -3856,81 +3856,12 @@
           <a:lstStyle/>
           <a:p>
             <a:r>
-              <a:rPr lang="ru-RU" sz="2400" dirty="0">
+              <a:rPr lang="ru-RU" sz="3200" dirty="0">
                 <a:latin typeface="Times New Roman" panose="02020603050405020304" pitchFamily="18" charset="0"/>
               </a:rPr>
               <a:t>Изменение функции пор по размерам </a:t>
             </a:r>
-            <a:endParaRPr lang="ru-RU" sz="2400" dirty="0"/>
-          </a:p>
-        </p:txBody>
-      </p:sp>
-      <p:sp>
-        <p:nvSpPr>
-          <p:cNvPr id="7" name="Rectangle 9">
-            <a:extLst>
-              <a:ext uri="{FF2B5EF4-FFF2-40B4-BE49-F238E27FC236}">
-                <a16:creationId xmlns:a16="http://schemas.microsoft.com/office/drawing/2014/main" id="{DD7A7757-612D-482A-95E5-57BBB9DC5769}"/>
-              </a:ext>
-            </a:extLst>
-          </p:cNvPr>
-          <p:cNvSpPr>
-            <a:spLocks noChangeArrowheads="1"/>
-          </p:cNvSpPr>
-          <p:nvPr/>
-        </p:nvSpPr>
-        <p:spPr bwMode="auto">
-          <a:xfrm flipV="1">
-            <a:off x="0" y="590896"/>
-            <a:ext cx="12922375" cy="45719"/>
-          </a:xfrm>
-          <a:prstGeom prst="rect">
-            <a:avLst/>
-          </a:prstGeom>
-          <a:noFill/>
-          <a:ln>
-            <a:noFill/>
-          </a:ln>
-          <a:effectLst/>
-          <a:extLst>
-            <a:ext uri="{909E8E84-426E-40DD-AFC4-6F175D3DCCD1}">
-              <a14:hiddenFill xmlns:a14="http://schemas.microsoft.com/office/drawing/2010/main">
-                <a:solidFill>
-                  <a:schemeClr val="accent1"/>
-                </a:solidFill>
-              </a14:hiddenFill>
-            </a:ext>
-            <a:ext uri="{91240B29-F687-4F45-9708-019B960494DF}">
-              <a14:hiddenLine xmlns:a14="http://schemas.microsoft.com/office/drawing/2010/main" w="9525">
-                <a:solidFill>
-                  <a:schemeClr val="tx1"/>
-                </a:solidFill>
-                <a:miter lim="800000"/>
-                <a:headEnd/>
-                <a:tailEnd/>
-              </a14:hiddenLine>
-            </a:ext>
-            <a:ext uri="{AF507438-7753-43E0-B8FC-AC1667EBCBE1}">
-              <a14:hiddenEffects xmlns:a14="http://schemas.microsoft.com/office/drawing/2010/main">
-                <a:effectLst>
-                  <a:outerShdw dist="35921" dir="2700000" algn="ctr" rotWithShape="0">
-                    <a:schemeClr val="bg2"/>
-                  </a:outerShdw>
-                </a:effectLst>
-              </a14:hiddenEffects>
-            </a:ext>
-          </a:extLst>
-        </p:spPr>
-        <p:txBody>
-          <a:bodyPr vert="horz" wrap="square" lIns="91440" tIns="45720" rIns="91440" bIns="45720" numCol="1" anchor="ctr" anchorCtr="0" compatLnSpc="1">
-            <a:prstTxWarp prst="textNoShape">
-              <a:avLst/>
-            </a:prstTxWarp>
-            <a:spAutoFit/>
-          </a:bodyPr>
-          <a:lstStyle/>
-          <a:p>
-            <a:endParaRPr lang="ru-RU"/>
+            <a:endParaRPr lang="ru-RU" sz="3200" dirty="0"/>
           </a:p>
         </p:txBody>
       </p:sp>
@@ -3951,9 +3882,9 @@
         <p:grpSpPr bwMode="auto">
           <a:xfrm>
             <a:off x="372879" y="1352898"/>
-            <a:ext cx="6500714" cy="5268690"/>
+            <a:ext cx="3638032" cy="5268690"/>
             <a:chOff x="2734" y="11896"/>
-            <a:chExt cx="6590" cy="7273"/>
+            <a:chExt cx="3688" cy="7273"/>
           </a:xfrm>
         </p:grpSpPr>
         <p:sp>
@@ -3972,7 +3903,7 @@
           </p:nvSpPr>
           <p:spPr bwMode="auto">
             <a:xfrm>
-              <a:off x="6422" y="15095"/>
+              <a:off x="3217" y="13815"/>
               <a:ext cx="2902" cy="425"/>
             </a:xfrm>
             <a:prstGeom prst="rect">
@@ -4159,7 +4090,7 @@
           </p:nvSpPr>
           <p:spPr bwMode="auto">
             <a:xfrm>
-              <a:off x="6422" y="17558"/>
+              <a:off x="3265" y="16365"/>
               <a:ext cx="2745" cy="283"/>
             </a:xfrm>
             <a:prstGeom prst="rect">
@@ -4300,7 +4231,7 @@
         </p:nvSpPr>
         <p:spPr bwMode="auto">
           <a:xfrm>
-            <a:off x="3856394" y="1846779"/>
+            <a:off x="849034" y="1003283"/>
             <a:ext cx="3016842" cy="253103"/>
           </a:xfrm>
           <a:prstGeom prst="rect">
@@ -4377,111 +4308,42 @@
           </a:p>
         </p:txBody>
       </p:sp>
-      <p:sp>
-        <p:nvSpPr>
-          <p:cNvPr id="20" name="Прямоугольник 19">
+      <p:pic>
+        <p:nvPicPr>
+          <p:cNvPr id="4" name="Рисунок 3">
             <a:extLst>
               <a:ext uri="{FF2B5EF4-FFF2-40B4-BE49-F238E27FC236}">
-                <a16:creationId xmlns:a16="http://schemas.microsoft.com/office/drawing/2014/main" id="{335B9E3A-7072-4C3E-9056-4FD6A025833D}"/>
+                <a16:creationId xmlns:a16="http://schemas.microsoft.com/office/drawing/2014/main" id="{7EC0CD64-E2C1-4576-A25E-E0C2CCB89960}"/>
               </a:ext>
             </a:extLst>
           </p:cNvPr>
-          <p:cNvSpPr/>
+          <p:cNvPicPr>
+            <a:picLocks noChangeAspect="1"/>
+          </p:cNvPicPr>
           <p:nvPr/>
-        </p:nvSpPr>
+        </p:nvPicPr>
+        <p:blipFill>
+          <a:blip r:embed="rId5">
+            <a:extLst>
+              <a:ext uri="{28A0092B-C50C-407E-A947-70E740481C1C}">
+                <a14:useLocalDpi xmlns:a14="http://schemas.microsoft.com/office/drawing/2010/main" val="0"/>
+              </a:ext>
+            </a:extLst>
+          </a:blip>
+          <a:stretch>
+            <a:fillRect/>
+          </a:stretch>
+        </p:blipFill>
         <p:spPr>
           <a:xfrm>
-            <a:off x="6718720" y="2296146"/>
-            <a:ext cx="5302592" cy="2598347"/>
+            <a:off x="4426971" y="1779617"/>
+            <a:ext cx="7508240" cy="3503846"/>
           </a:xfrm>
           <a:prstGeom prst="rect">
             <a:avLst/>
           </a:prstGeom>
-          <a:solidFill>
-            <a:schemeClr val="bg1"/>
-          </a:solidFill>
         </p:spPr>
-        <p:style>
-          <a:lnRef idx="2">
-            <a:schemeClr val="accent1">
-              <a:shade val="50000"/>
-            </a:schemeClr>
-          </a:lnRef>
-          <a:fillRef idx="1">
-            <a:schemeClr val="accent1"/>
-          </a:fillRef>
-          <a:effectRef idx="0">
-            <a:schemeClr val="accent1"/>
-          </a:effectRef>
-          <a:fontRef idx="minor">
-            <a:schemeClr val="lt1"/>
-          </a:fontRef>
-        </p:style>
-        <p:txBody>
-          <a:bodyPr rtlCol="0" anchor="ctr"/>
-          <a:lstStyle/>
-          <a:p>
-            <a:pPr algn="ctr"/>
-            <a:endParaRPr lang="ru-RU"/>
-          </a:p>
-        </p:txBody>
-      </p:sp>
-      <p:sp>
-        <p:nvSpPr>
-          <p:cNvPr id="21" name="TextBox 20">
-            <a:extLst>
-              <a:ext uri="{FF2B5EF4-FFF2-40B4-BE49-F238E27FC236}">
-                <a16:creationId xmlns:a16="http://schemas.microsoft.com/office/drawing/2014/main" id="{CD130854-0678-42F1-BE3F-0932F562DD84}"/>
-              </a:ext>
-            </a:extLst>
-          </p:cNvPr>
-          <p:cNvSpPr txBox="1"/>
-          <p:nvPr/>
-        </p:nvSpPr>
-        <p:spPr>
-          <a:xfrm>
-            <a:off x="7835005" y="3391097"/>
-            <a:ext cx="3647890" cy="646331"/>
-          </a:xfrm>
-          <a:prstGeom prst="rect">
-            <a:avLst/>
-          </a:prstGeom>
-          <a:noFill/>
-        </p:spPr>
-        <p:txBody>
-          <a:bodyPr wrap="square">
-            <a:spAutoFit/>
-          </a:bodyPr>
-          <a:lstStyle/>
-          <a:p>
-            <a:r>
-              <a:rPr lang="ru-RU" sz="1800" dirty="0">
-                <a:effectLst/>
-                <a:latin typeface="Times New Roman" panose="02020603050405020304" pitchFamily="18" charset="0"/>
-                <a:ea typeface="Calibri" panose="020F0502020204030204" pitchFamily="34" charset="0"/>
-              </a:rPr>
-              <a:t>Красивая </a:t>
-            </a:r>
-            <a:r>
-              <a:rPr lang="en-US" sz="1800" dirty="0">
-                <a:effectLst/>
-                <a:latin typeface="Times New Roman" panose="02020603050405020304" pitchFamily="18" charset="0"/>
-                <a:ea typeface="Calibri" panose="020F0502020204030204" pitchFamily="34" charset="0"/>
-              </a:rPr>
-              <a:t>gif-</a:t>
-            </a:r>
-            <a:r>
-              <a:rPr lang="ru-RU" sz="1800" dirty="0">
-                <a:effectLst/>
-                <a:latin typeface="Times New Roman" panose="02020603050405020304" pitchFamily="18" charset="0"/>
-                <a:ea typeface="Calibri" panose="020F0502020204030204" pitchFamily="34" charset="0"/>
-              </a:rPr>
-              <a:t>анимация изменения функции пор по размерам</a:t>
-            </a:r>
-            <a:endParaRPr lang="ru-RU" dirty="0"/>
-          </a:p>
-        </p:txBody>
-      </p:sp>
+      </p:pic>
     </p:spTree>
     <p:extLst>
       <p:ext uri="{BB962C8B-B14F-4D97-AF65-F5344CB8AC3E}">
@@ -5259,8 +5121,8 @@
           </p:txBody>
         </p:sp>
       </p:grpSp>
-      <mc:AlternateContent xmlns:mc="http://schemas.openxmlformats.org/markup-compatibility/2006">
-        <mc:Choice xmlns:a14="http://schemas.microsoft.com/office/drawing/2010/main" Requires="a14">
+      <mc:AlternateContent xmlns:mc="http://schemas.openxmlformats.org/markup-compatibility/2006" xmlns:a14="http://schemas.microsoft.com/office/drawing/2010/main">
+        <mc:Choice Requires="a14">
           <p:sp>
             <p:nvSpPr>
               <p:cNvPr id="25" name="TextBox 24">
@@ -5504,7 +5366,7 @@
             </p:txBody>
           </p:sp>
         </mc:Choice>
-        <mc:Fallback>
+        <mc:Fallback xmlns="">
           <p:sp>
             <p:nvSpPr>
               <p:cNvPr id="25" name="TextBox 24">
@@ -9126,8 +8988,8 @@
           </a:p>
         </p:txBody>
       </p:sp>
-      <mc:AlternateContent xmlns:mc="http://schemas.openxmlformats.org/markup-compatibility/2006">
-        <mc:Choice xmlns:a14="http://schemas.microsoft.com/office/drawing/2010/main" Requires="a14">
+      <mc:AlternateContent xmlns:mc="http://schemas.openxmlformats.org/markup-compatibility/2006" xmlns:a14="http://schemas.microsoft.com/office/drawing/2010/main">
+        <mc:Choice Requires="a14">
           <p:sp>
             <p:nvSpPr>
               <p:cNvPr id="5" name="TextBox 4">
@@ -9594,7 +9456,7 @@
             </p:txBody>
           </p:sp>
         </mc:Choice>
-        <mc:Fallback>
+        <mc:Fallback xmlns="">
           <p:sp>
             <p:nvSpPr>
               <p:cNvPr id="5" name="TextBox 4">
@@ -9639,8 +9501,8 @@
           </p:sp>
         </mc:Fallback>
       </mc:AlternateContent>
-      <mc:AlternateContent xmlns:mc="http://schemas.openxmlformats.org/markup-compatibility/2006">
-        <mc:Choice xmlns:a14="http://schemas.microsoft.com/office/drawing/2010/main" Requires="a14">
+      <mc:AlternateContent xmlns:mc="http://schemas.openxmlformats.org/markup-compatibility/2006" xmlns:a14="http://schemas.microsoft.com/office/drawing/2010/main">
+        <mc:Choice Requires="a14">
           <p:sp>
             <p:nvSpPr>
               <p:cNvPr id="6" name="TextBox 5">
@@ -10194,7 +10056,7 @@
             </p:txBody>
           </p:sp>
         </mc:Choice>
-        <mc:Fallback>
+        <mc:Fallback xmlns="">
           <p:sp>
             <p:nvSpPr>
               <p:cNvPr id="6" name="TextBox 5">
@@ -15541,8 +15403,8 @@
         </p:nvSpPr>
         <p:spPr>
           <a:xfrm>
-            <a:off x="554967" y="636615"/>
-            <a:ext cx="6156960" cy="461665"/>
+            <a:off x="453366" y="343883"/>
+            <a:ext cx="7528403" cy="584775"/>
           </a:xfrm>
           <a:prstGeom prst="rect">
             <a:avLst/>
@@ -15556,12 +15418,12 @@
           <a:lstStyle/>
           <a:p>
             <a:r>
-              <a:rPr lang="ru-RU" sz="2400" dirty="0">
+              <a:rPr lang="ru-RU" sz="3200" dirty="0">
                 <a:latin typeface="Times New Roman" panose="02020603050405020304" pitchFamily="18" charset="0"/>
               </a:rPr>
               <a:t>Структурные изменения пористой среды</a:t>
             </a:r>
-            <a:endParaRPr lang="ru-RU" sz="2400" dirty="0"/>
+            <a:endParaRPr lang="ru-RU" sz="3200" dirty="0"/>
           </a:p>
         </p:txBody>
       </p:sp>

</xml_diff>